<commit_message>
docs: update Figma prototype link in docs and presentation
Point all Figma references to the interactive prototype page and regenerate the submission presentation.

Co-authored-by: Cursor <cursoragent@cursor.com>
</commit_message>
<xml_diff>
--- a/Квизы — МарковаТА.pptx
+++ b/Квизы — МарковаТА.pptx
@@ -320,7 +320,7 @@
           <a:p>
             <a:fld id="{5BCAD085-E8A6-8845-BD4E-CB4CCA059FC4}" type="datetimeFigureOut">
               <a:rPr lang="en-US" smtClean="0"/>
-              <a:t>6/7/2026</a:t>
+              <a:t>6/8/2026</a:t>
             </a:fld>
             <a:endParaRPr lang="en-US"/>
           </a:p>
@@ -488,7 +488,7 @@
           <a:p>
             <a:fld id="{5BCAD085-E8A6-8845-BD4E-CB4CCA059FC4}" type="datetimeFigureOut">
               <a:rPr lang="en-US" smtClean="0"/>
-              <a:t>6/7/2026</a:t>
+              <a:t>6/8/2026</a:t>
             </a:fld>
             <a:endParaRPr lang="en-US"/>
           </a:p>
@@ -666,7 +666,7 @@
           <a:p>
             <a:fld id="{5BCAD085-E8A6-8845-BD4E-CB4CCA059FC4}" type="datetimeFigureOut">
               <a:rPr lang="en-US" smtClean="0"/>
-              <a:t>6/7/2026</a:t>
+              <a:t>6/8/2026</a:t>
             </a:fld>
             <a:endParaRPr lang="en-US"/>
           </a:p>
@@ -834,7 +834,7 @@
           <a:p>
             <a:fld id="{5BCAD085-E8A6-8845-BD4E-CB4CCA059FC4}" type="datetimeFigureOut">
               <a:rPr lang="en-US" smtClean="0"/>
-              <a:t>6/7/2026</a:t>
+              <a:t>6/8/2026</a:t>
             </a:fld>
             <a:endParaRPr lang="en-US"/>
           </a:p>
@@ -1079,7 +1079,7 @@
           <a:p>
             <a:fld id="{5BCAD085-E8A6-8845-BD4E-CB4CCA059FC4}" type="datetimeFigureOut">
               <a:rPr lang="en-US" smtClean="0"/>
-              <a:t>6/7/2026</a:t>
+              <a:t>6/8/2026</a:t>
             </a:fld>
             <a:endParaRPr lang="en-US"/>
           </a:p>
@@ -1364,7 +1364,7 @@
           <a:p>
             <a:fld id="{5BCAD085-E8A6-8845-BD4E-CB4CCA059FC4}" type="datetimeFigureOut">
               <a:rPr lang="en-US" smtClean="0"/>
-              <a:t>6/7/2026</a:t>
+              <a:t>6/8/2026</a:t>
             </a:fld>
             <a:endParaRPr lang="en-US"/>
           </a:p>
@@ -1783,7 +1783,7 @@
           <a:p>
             <a:fld id="{5BCAD085-E8A6-8845-BD4E-CB4CCA059FC4}" type="datetimeFigureOut">
               <a:rPr lang="en-US" smtClean="0"/>
-              <a:t>6/7/2026</a:t>
+              <a:t>6/8/2026</a:t>
             </a:fld>
             <a:endParaRPr lang="en-US"/>
           </a:p>
@@ -1900,7 +1900,7 @@
           <a:p>
             <a:fld id="{5BCAD085-E8A6-8845-BD4E-CB4CCA059FC4}" type="datetimeFigureOut">
               <a:rPr lang="en-US" smtClean="0"/>
-              <a:t>6/7/2026</a:t>
+              <a:t>6/8/2026</a:t>
             </a:fld>
             <a:endParaRPr lang="en-US"/>
           </a:p>
@@ -1995,7 +1995,7 @@
           <a:p>
             <a:fld id="{5BCAD085-E8A6-8845-BD4E-CB4CCA059FC4}" type="datetimeFigureOut">
               <a:rPr lang="en-US" smtClean="0"/>
-              <a:t>6/7/2026</a:t>
+              <a:t>6/8/2026</a:t>
             </a:fld>
             <a:endParaRPr lang="en-US"/>
           </a:p>
@@ -2270,7 +2270,7 @@
           <a:p>
             <a:fld id="{5BCAD085-E8A6-8845-BD4E-CB4CCA059FC4}" type="datetimeFigureOut">
               <a:rPr lang="en-US" smtClean="0"/>
-              <a:t>6/7/2026</a:t>
+              <a:t>6/8/2026</a:t>
             </a:fld>
             <a:endParaRPr lang="en-US"/>
           </a:p>
@@ -2522,7 +2522,7 @@
           <a:p>
             <a:fld id="{5BCAD085-E8A6-8845-BD4E-CB4CCA059FC4}" type="datetimeFigureOut">
               <a:rPr lang="en-US" smtClean="0"/>
-              <a:t>6/7/2026</a:t>
+              <a:t>6/8/2026</a:t>
             </a:fld>
             <a:endParaRPr lang="en-US"/>
           </a:p>
@@ -2733,7 +2733,7 @@
           <a:p>
             <a:fld id="{5BCAD085-E8A6-8845-BD4E-CB4CCA059FC4}" type="datetimeFigureOut">
               <a:rPr lang="en-US" smtClean="0"/>
-              <a:t>6/7/2026</a:t>
+              <a:t>6/8/2026</a:t>
             </a:fld>
             <a:endParaRPr lang="en-US"/>
           </a:p>
@@ -6069,20 +6069,20 @@
         <p:spPr>
           <a:xfrm>
             <a:off x="4114800" y="1298448"/>
-            <a:ext cx="7132320" cy="457200"/>
-          </a:xfrm>
-          <a:prstGeom prst="rect">
-            <a:avLst/>
-          </a:prstGeom>
-          <a:noFill/>
-        </p:spPr>
-        <p:txBody>
-          <a:bodyPr wrap="square">
-            <a:spAutoFit/>
-          </a:bodyPr>
-          <a:lstStyle/>
-          <a:p>
-            <a:pPr algn="l">
+            <a:ext cx="7132320" cy="830997"/>
+          </a:xfrm>
+          <a:prstGeom prst="rect">
+            <a:avLst/>
+          </a:prstGeom>
+          <a:noFill/>
+        </p:spPr>
+        <p:txBody>
+          <a:bodyPr wrap="square">
+            <a:spAutoFit/>
+          </a:bodyPr>
+          <a:lstStyle/>
+          <a:p>
+            <a:pPr>
               <a:defRPr sz="1200" b="0">
                 <a:solidFill>
                   <a:srgbClr val="5C677A"/>
@@ -6091,15 +6091,26 @@
               </a:defRPr>
             </a:pPr>
             <a:r>
-              <a:rPr dirty="0">
+              <a:rPr lang="en-US" dirty="0">
                 <a:hlinkClick r:id="rId2"/>
               </a:rPr>
-              <a:t>https://www.figma.com/design/bowNce537o2YiRGUxFzpAH</a:t>
+              <a:t>https://www.figma.com/design/bowNce537o2YiRGUxFzpAH/%D0%9A%D0%B2%D0%B8%D0%B7%D1%8B?node-id=19-2&amp;t=4qwjaL7DsbURMhLS-1</a:t>
             </a:r>
             <a:endParaRPr lang="ru-RU" dirty="0"/>
           </a:p>
           <a:p>
-            <a:pPr algn="l">
+            <a:pPr>
+              <a:defRPr sz="1200" b="0">
+                <a:solidFill>
+                  <a:srgbClr val="5C677A"/>
+                </a:solidFill>
+                <a:latin typeface="Segoe UI"/>
+              </a:defRPr>
+            </a:pPr>
+            <a:endParaRPr lang="ru-RU" dirty="0"/>
+          </a:p>
+          <a:p>
+            <a:pPr>
               <a:defRPr sz="1200" b="0">
                 <a:solidFill>
                   <a:srgbClr val="5C677A"/>

</xml_diff>